<commit_message>
Updated ETL pipeline, analytics notebooks and processed outputs
</commit_message>
<xml_diff>
--- a/reports/Presentation.pptx
+++ b/reports/Presentation.pptx
@@ -201,7 +201,7 @@
             <a:fld id="{F6CD5D19-666C-420B-B7DA-CE0639795B37}" type="datetimeFigureOut">
               <a:rPr lang="en-US" smtClean="0"/>
               <a:pPr/>
-              <a:t>6/11/2026</a:t>
+              <a:t>6/12/2026</a:t>
             </a:fld>
             <a:endParaRPr lang="en-US"/>
           </a:p>
@@ -687,7 +687,7 @@
             <a:fld id="{D9C8B1AA-D486-4B6C-8C35-7A001614DAD6}" type="datetimeFigureOut">
               <a:rPr lang="en-US" smtClean="0"/>
               <a:pPr/>
-              <a:t>6/11/2026</a:t>
+              <a:t>6/12/2026</a:t>
             </a:fld>
             <a:endParaRPr lang="en-US"/>
           </a:p>
@@ -1558,7 +1558,7 @@
             <a:fld id="{D9C8B1AA-D486-4B6C-8C35-7A001614DAD6}" type="datetimeFigureOut">
               <a:rPr lang="en-US" smtClean="0"/>
               <a:pPr/>
-              <a:t>6/11/2026</a:t>
+              <a:t>6/12/2026</a:t>
             </a:fld>
             <a:endParaRPr lang="en-US"/>
           </a:p>
@@ -1735,7 +1735,7 @@
             <a:fld id="{D9C8B1AA-D486-4B6C-8C35-7A001614DAD6}" type="datetimeFigureOut">
               <a:rPr lang="en-US" smtClean="0"/>
               <a:pPr/>
-              <a:t>6/11/2026</a:t>
+              <a:t>6/12/2026</a:t>
             </a:fld>
             <a:endParaRPr lang="en-US"/>
           </a:p>
@@ -1907,7 +1907,7 @@
             <a:fld id="{D9C8B1AA-D486-4B6C-8C35-7A001614DAD6}" type="datetimeFigureOut">
               <a:rPr lang="en-US" smtClean="0"/>
               <a:pPr/>
-              <a:t>6/11/2026</a:t>
+              <a:t>6/12/2026</a:t>
             </a:fld>
             <a:endParaRPr lang="en-US"/>
           </a:p>
@@ -2119,7 +2119,7 @@
             <a:fld id="{D9C8B1AA-D486-4B6C-8C35-7A001614DAD6}" type="datetimeFigureOut">
               <a:rPr lang="en-US" smtClean="0"/>
               <a:pPr/>
-              <a:t>6/11/2026</a:t>
+              <a:t>6/12/2026</a:t>
             </a:fld>
             <a:endParaRPr lang="en-US"/>
           </a:p>
@@ -2935,7 +2935,7 @@
             <a:fld id="{D9C8B1AA-D486-4B6C-8C35-7A001614DAD6}" type="datetimeFigureOut">
               <a:rPr lang="en-US" smtClean="0"/>
               <a:pPr/>
-              <a:t>6/11/2026</a:t>
+              <a:t>6/12/2026</a:t>
             </a:fld>
             <a:endParaRPr lang="en-US"/>
           </a:p>
@@ -3173,7 +3173,7 @@
             <a:fld id="{D9C8B1AA-D486-4B6C-8C35-7A001614DAD6}" type="datetimeFigureOut">
               <a:rPr lang="en-US" smtClean="0"/>
               <a:pPr/>
-              <a:t>6/11/2026</a:t>
+              <a:t>6/12/2026</a:t>
             </a:fld>
             <a:endParaRPr lang="en-US"/>
           </a:p>
@@ -3498,7 +3498,7 @@
             <a:fld id="{D9C8B1AA-D486-4B6C-8C35-7A001614DAD6}" type="datetimeFigureOut">
               <a:rPr lang="en-US" smtClean="0"/>
               <a:pPr/>
-              <a:t>6/11/2026</a:t>
+              <a:t>6/12/2026</a:t>
             </a:fld>
             <a:endParaRPr lang="en-US"/>
           </a:p>
@@ -3590,7 +3590,7 @@
             <a:fld id="{D9C8B1AA-D486-4B6C-8C35-7A001614DAD6}" type="datetimeFigureOut">
               <a:rPr lang="en-US" smtClean="0"/>
               <a:pPr/>
-              <a:t>6/11/2026</a:t>
+              <a:t>6/12/2026</a:t>
             </a:fld>
             <a:endParaRPr lang="en-US"/>
           </a:p>
@@ -4109,7 +4109,7 @@
             <a:fld id="{D9C8B1AA-D486-4B6C-8C35-7A001614DAD6}" type="datetimeFigureOut">
               <a:rPr lang="en-US" smtClean="0"/>
               <a:pPr/>
-              <a:t>6/11/2026</a:t>
+              <a:t>6/12/2026</a:t>
             </a:fld>
             <a:endParaRPr lang="en-US"/>
           </a:p>
@@ -4622,7 +4622,7 @@
             <a:fld id="{D9C8B1AA-D486-4B6C-8C35-7A001614DAD6}" type="datetimeFigureOut">
               <a:rPr lang="en-US" smtClean="0"/>
               <a:pPr/>
-              <a:t>6/11/2026</a:t>
+              <a:t>6/12/2026</a:t>
             </a:fld>
             <a:endParaRPr lang="en-US"/>
           </a:p>
@@ -4869,7 +4869,7 @@
             <a:fld id="{D9C8B1AA-D486-4B6C-8C35-7A001614DAD6}" type="datetimeFigureOut">
               <a:rPr lang="en-US" smtClean="0"/>
               <a:pPr/>
-              <a:t>6/11/2026</a:t>
+              <a:t>6/12/2026</a:t>
             </a:fld>
             <a:endParaRPr lang="en-US"/>
           </a:p>
@@ -5491,12 +5491,12 @@
           <a:lstStyle/>
           <a:p>
             <a:r>
-              <a:rPr lang="en-US" dirty="0" err="1" smtClean="0"/>
-              <a:t>Bluestock</a:t>
-            </a:r>
-            <a:r>
               <a:rPr lang="en-US" dirty="0" smtClean="0"/>
-              <a:t> Mutual Fund Analytics Project</a:t>
+              <a:t>Mutual </a:t>
+            </a:r>
+            <a:r>
+              <a:rPr lang="en-US" dirty="0" smtClean="0"/>
+              <a:t>Fund Analytics Project</a:t>
             </a:r>
             <a:endParaRPr lang="en-US" dirty="0"/>
           </a:p>
@@ -5808,7 +5808,7 @@
         <p:spPr>
           <a:xfrm>
             <a:off x="467544" y="260648"/>
-            <a:ext cx="7467600" cy="1008112"/>
+            <a:ext cx="7467600" cy="936104"/>
           </a:xfrm>
         </p:spPr>
         <p:txBody>
@@ -5835,169 +5835,104 @@
         </p:nvSpPr>
         <p:spPr>
           <a:xfrm>
-            <a:off x="457200" y="1412776"/>
-            <a:ext cx="7467600" cy="5061176"/>
+            <a:off x="611560" y="1412776"/>
+            <a:ext cx="7313240" cy="5061176"/>
           </a:xfrm>
         </p:spPr>
         <p:txBody>
           <a:bodyPr numCol="1">
-            <a:normAutofit fontScale="92500" lnSpcReduction="20000"/>
+            <a:normAutofit lnSpcReduction="10000"/>
           </a:bodyPr>
           <a:lstStyle/>
-          <a:p>
-            <a:pPr algn="r">
-              <a:buNone/>
-            </a:pPr>
-            <a:r>
-              <a:rPr lang="en-US" sz="1400" dirty="0" smtClean="0"/>
-              <a:t>Raw CSV </a:t>
-            </a:r>
-            <a:r>
-              <a:rPr lang="en-US" sz="1400" dirty="0" smtClean="0"/>
-              <a:t>Files</a:t>
-            </a:r>
-          </a:p>
-          <a:p>
-            <a:pPr algn="r">
-              <a:buNone/>
-            </a:pPr>
-            <a:r>
-              <a:rPr lang="en-US" sz="1400" dirty="0" smtClean="0"/>
-              <a:t>      ↓   </a:t>
-            </a:r>
-          </a:p>
-          <a:p>
-            <a:pPr algn="r">
-              <a:buNone/>
-            </a:pPr>
-            <a:r>
-              <a:rPr lang="en-US" sz="1400" dirty="0" smtClean="0"/>
-              <a:t>Data </a:t>
-            </a:r>
-            <a:r>
-              <a:rPr lang="en-US" sz="1400" dirty="0" smtClean="0"/>
-              <a:t>Cleaning &amp; Validation</a:t>
-            </a:r>
-          </a:p>
-          <a:p>
-            <a:pPr algn="r">
-              <a:buNone/>
-            </a:pPr>
-            <a:r>
-              <a:rPr lang="en-US" sz="1400" dirty="0" smtClean="0"/>
-              <a:t>      ↓</a:t>
-            </a:r>
-          </a:p>
-          <a:p>
-            <a:pPr algn="r">
-              <a:buNone/>
-            </a:pPr>
-            <a:r>
-              <a:rPr lang="en-US" sz="1400" dirty="0" err="1" smtClean="0"/>
-              <a:t>SQLite</a:t>
-            </a:r>
-            <a:r>
-              <a:rPr lang="en-US" sz="1400" dirty="0" smtClean="0"/>
-              <a:t> Database</a:t>
-            </a:r>
-          </a:p>
-          <a:p>
-            <a:pPr algn="r">
-              <a:buNone/>
-            </a:pPr>
-            <a:r>
-              <a:rPr lang="en-US" sz="1400" dirty="0" smtClean="0"/>
-              <a:t>      ↓</a:t>
-            </a:r>
-          </a:p>
-          <a:p>
-            <a:pPr algn="r">
-              <a:buNone/>
-            </a:pPr>
-            <a:r>
-              <a:rPr lang="en-US" sz="1400" dirty="0" smtClean="0"/>
-              <a:t>Exploratory Data Analysis</a:t>
-            </a:r>
-          </a:p>
-          <a:p>
-            <a:pPr algn="r">
-              <a:buNone/>
-            </a:pPr>
-            <a:r>
-              <a:rPr lang="en-US" sz="1400" dirty="0" smtClean="0"/>
-              <a:t>      ↓</a:t>
-            </a:r>
-          </a:p>
-          <a:p>
-            <a:pPr algn="r">
-              <a:buNone/>
-            </a:pPr>
-            <a:r>
-              <a:rPr lang="en-US" sz="1400" dirty="0" smtClean="0"/>
-              <a:t>Performance Analytics</a:t>
-            </a:r>
-          </a:p>
-          <a:p>
-            <a:pPr algn="r">
-              <a:buNone/>
-            </a:pPr>
-            <a:r>
-              <a:rPr lang="en-US" sz="1400" dirty="0" smtClean="0"/>
-              <a:t>      ↓</a:t>
-            </a:r>
-          </a:p>
-          <a:p>
-            <a:pPr algn="r">
-              <a:buNone/>
-            </a:pPr>
-            <a:r>
-              <a:rPr lang="en-US" sz="1400" dirty="0" smtClean="0"/>
-              <a:t>Advanced Risk Analytics</a:t>
-            </a:r>
-          </a:p>
-          <a:p>
-            <a:pPr algn="r">
-              <a:buNone/>
-            </a:pPr>
-            <a:r>
-              <a:rPr lang="en-US" sz="1400" dirty="0" smtClean="0"/>
-              <a:t>      ↓</a:t>
-            </a:r>
-          </a:p>
-          <a:p>
-            <a:pPr algn="r">
-              <a:buNone/>
-            </a:pPr>
-            <a:r>
-              <a:rPr lang="en-US" sz="1400" dirty="0" smtClean="0"/>
-              <a:t>Power BI Dashboard</a:t>
-            </a:r>
-          </a:p>
-          <a:p>
-            <a:pPr algn="r">
-              <a:buNone/>
-            </a:pPr>
-            <a:r>
-              <a:rPr lang="en-US" sz="1400" dirty="0" smtClean="0"/>
-              <a:t>      ↓</a:t>
-            </a:r>
-          </a:p>
-          <a:p>
-            <a:pPr algn="r">
-              <a:buNone/>
-            </a:pPr>
-            <a:r>
-              <a:rPr lang="en-US" sz="1400" dirty="0" smtClean="0"/>
-              <a:t>Business Insights</a:t>
-            </a:r>
-          </a:p>
           <a:p>
             <a:pPr>
               <a:buNone/>
             </a:pPr>
+            <a:endParaRPr lang="en-US" sz="1400" b="1" dirty="0" smtClean="0"/>
+          </a:p>
+          <a:p>
+            <a:pPr>
+              <a:buNone/>
+            </a:pPr>
+            <a:endParaRPr lang="en-US" sz="1400" b="1" dirty="0" smtClean="0"/>
+          </a:p>
+          <a:p>
+            <a:pPr>
+              <a:buNone/>
+            </a:pPr>
+            <a:endParaRPr lang="en-US" sz="1400" b="1" dirty="0" smtClean="0"/>
+          </a:p>
+          <a:p>
+            <a:pPr>
+              <a:buNone/>
+            </a:pPr>
+            <a:endParaRPr lang="en-US" sz="1400" b="1" dirty="0" smtClean="0"/>
+          </a:p>
+          <a:p>
+            <a:pPr>
+              <a:buNone/>
+            </a:pPr>
+            <a:endParaRPr lang="en-US" sz="1400" b="1" dirty="0" smtClean="0"/>
+          </a:p>
+          <a:p>
+            <a:pPr>
+              <a:buNone/>
+            </a:pPr>
+            <a:endParaRPr lang="en-US" sz="1400" b="1" dirty="0" smtClean="0"/>
+          </a:p>
+          <a:p>
+            <a:pPr>
+              <a:buNone/>
+            </a:pPr>
+            <a:endParaRPr lang="en-US" sz="1400" b="1" dirty="0" smtClean="0"/>
+          </a:p>
+          <a:p>
+            <a:pPr>
+              <a:buNone/>
+            </a:pPr>
+            <a:endParaRPr lang="en-US" sz="1400" b="1" dirty="0" smtClean="0"/>
+          </a:p>
+          <a:p>
+            <a:pPr>
+              <a:buNone/>
+            </a:pPr>
+            <a:endParaRPr lang="en-US" sz="1400" b="1" dirty="0" smtClean="0"/>
+          </a:p>
+          <a:p>
+            <a:pPr>
+              <a:buNone/>
+            </a:pPr>
+            <a:endParaRPr lang="en-US" sz="1400" b="1" dirty="0" smtClean="0"/>
+          </a:p>
+          <a:p>
+            <a:pPr>
+              <a:buNone/>
+            </a:pPr>
+            <a:endParaRPr lang="en-US" sz="1400" b="1" dirty="0" smtClean="0"/>
+          </a:p>
+          <a:p>
+            <a:pPr>
+              <a:buNone/>
+            </a:pPr>
+            <a:endParaRPr lang="en-US" sz="1400" b="1" dirty="0" smtClean="0"/>
+          </a:p>
+          <a:p>
+            <a:pPr>
+              <a:buNone/>
+            </a:pPr>
+            <a:endParaRPr lang="en-US" sz="1400" b="1" dirty="0" smtClean="0"/>
+          </a:p>
+          <a:p>
+            <a:pPr>
+              <a:buNone/>
+            </a:pPr>
             <a:r>
               <a:rPr lang="en-US" sz="1400" b="1" dirty="0" smtClean="0"/>
-              <a:t>Tools Used</a:t>
+              <a:t>Tools </a:t>
+            </a:r>
+            <a:r>
+              <a:rPr lang="en-US" sz="1400" b="1" dirty="0" smtClean="0"/>
+              <a:t>Used</a:t>
             </a:r>
           </a:p>
           <a:p>
@@ -6042,7 +5977,7 @@
       </p:sp>
       <p:pic>
         <p:nvPicPr>
-          <p:cNvPr id="4" name="Picture 3" descr="Screenshot 2026-06-10 234325.png"/>
+          <p:cNvPr id="5" name="Picture 4" descr="Screenshot 2026-06-12 153023.png"/>
           <p:cNvPicPr>
             <a:picLocks noChangeAspect="1"/>
           </p:cNvPicPr>
@@ -6056,12 +5991,22 @@
         </p:blipFill>
         <p:spPr>
           <a:xfrm>
-            <a:off x="683568" y="1484784"/>
-            <a:ext cx="2736304" cy="3240360"/>
+            <a:off x="611560" y="1340768"/>
+            <a:ext cx="3226139" cy="3308684"/>
           </a:xfrm>
           <a:prstGeom prst="rect">
             <a:avLst/>
           </a:prstGeom>
+          <a:ln>
+            <a:noFill/>
+          </a:ln>
+          <a:effectLst>
+            <a:outerShdw blurRad="292100" dist="139700" dir="2700000" algn="tl" rotWithShape="0">
+              <a:srgbClr val="333333">
+                <a:alpha val="65000"/>
+              </a:srgbClr>
+            </a:outerShdw>
+          </a:effectLst>
         </p:spPr>
       </p:pic>
     </p:spTree>
@@ -6150,11 +6095,7 @@
             </a:pPr>
             <a:r>
               <a:rPr lang="en-US" sz="1400" dirty="0" smtClean="0"/>
-              <a:t>Industry folios increased from 13.26 Cr to 26.12 Cr</a:t>
-            </a:r>
-            <a:r>
-              <a:rPr lang="en-US" sz="1400" dirty="0" smtClean="0"/>
-              <a:t>.</a:t>
+              <a:t>Industry folios increased from 13.26 Cr to 26.12 Cr.</a:t>
             </a:r>
           </a:p>
           <a:p>
@@ -6164,13 +6105,8 @@
             </a:pPr>
             <a:r>
               <a:rPr lang="en-US" sz="1400" dirty="0" smtClean="0"/>
-              <a:t> </a:t>
-            </a:r>
-            <a:r>
-              <a:rPr lang="en-US" sz="1400" dirty="0" smtClean="0"/>
-              <a:t>SIP inflows reached record highs in 2025. </a:t>
-            </a:r>
-            <a:endParaRPr lang="en-US" sz="1400" dirty="0" smtClean="0"/>
+              <a:t> SIP inflows reached record highs in 2025. </a:t>
+            </a:r>
           </a:p>
           <a:p>
             <a:pPr marL="457200" indent="-457200" algn="just">
@@ -6179,13 +6115,8 @@
             </a:pPr>
             <a:r>
               <a:rPr lang="en-US" sz="1400" dirty="0" smtClean="0"/>
-              <a:t>SBI </a:t>
-            </a:r>
-            <a:r>
-              <a:rPr lang="en-US" sz="1400" dirty="0" smtClean="0"/>
-              <a:t>Mutual Fund maintained the highest AUM. </a:t>
-            </a:r>
-            <a:endParaRPr lang="en-US" sz="1400" dirty="0" smtClean="0"/>
+              <a:t>SBI Mutual Fund maintained the highest AUM. </a:t>
+            </a:r>
           </a:p>
           <a:p>
             <a:pPr marL="457200" indent="-457200" algn="just">
@@ -6194,13 +6125,8 @@
             </a:pPr>
             <a:r>
               <a:rPr lang="en-US" sz="1400" dirty="0" smtClean="0"/>
-              <a:t>Equity-oriented </a:t>
-            </a:r>
-            <a:r>
-              <a:rPr lang="en-US" sz="1400" dirty="0" smtClean="0"/>
-              <a:t>funds attracted the largest investor participation. </a:t>
-            </a:r>
-            <a:endParaRPr lang="en-US" sz="1400" dirty="0" smtClean="0"/>
+              <a:t>Equity-oriented funds attracted the largest investor participation. </a:t>
+            </a:r>
           </a:p>
           <a:p>
             <a:pPr marL="457200" indent="-457200" algn="just">
@@ -6209,13 +6135,8 @@
             </a:pPr>
             <a:r>
               <a:rPr lang="en-US" sz="1400" dirty="0" smtClean="0"/>
-              <a:t>T30 </a:t>
-            </a:r>
-            <a:r>
-              <a:rPr lang="en-US" sz="1400" dirty="0" smtClean="0"/>
-              <a:t>cities contributed the majority of investments. </a:t>
-            </a:r>
-            <a:endParaRPr lang="en-US" sz="1400" dirty="0" smtClean="0"/>
+              <a:t>T30 cities contributed the majority of investments. </a:t>
+            </a:r>
           </a:p>
           <a:p>
             <a:pPr marL="457200" indent="-457200" algn="just">
@@ -6224,13 +6145,8 @@
             </a:pPr>
             <a:r>
               <a:rPr lang="en-US" sz="1400" dirty="0" smtClean="0"/>
-              <a:t>Male </a:t>
-            </a:r>
-            <a:r>
-              <a:rPr lang="en-US" sz="1400" dirty="0" smtClean="0"/>
-              <a:t>investors represented a larger transaction share. </a:t>
-            </a:r>
-            <a:endParaRPr lang="en-US" sz="1400" dirty="0" smtClean="0"/>
+              <a:t>Male investors represented a larger transaction share. </a:t>
+            </a:r>
           </a:p>
           <a:p>
             <a:pPr marL="457200" indent="-457200" algn="just">
@@ -6239,13 +6155,8 @@
             </a:pPr>
             <a:r>
               <a:rPr lang="en-US" sz="1400" dirty="0" smtClean="0"/>
-              <a:t>Small-cap </a:t>
-            </a:r>
-            <a:r>
-              <a:rPr lang="en-US" sz="1400" dirty="0" smtClean="0"/>
-              <a:t>funds delivered higher returns with higher risk. </a:t>
-            </a:r>
-            <a:endParaRPr lang="en-US" sz="1400" dirty="0" smtClean="0"/>
+              <a:t>Small-cap funds delivered higher returns with higher risk. </a:t>
+            </a:r>
           </a:p>
           <a:p>
             <a:pPr marL="457200" indent="-457200" algn="just">
@@ -6254,13 +6165,8 @@
             </a:pPr>
             <a:r>
               <a:rPr lang="en-US" sz="1400" dirty="0" smtClean="0"/>
-              <a:t>Monthly </a:t>
-            </a:r>
-            <a:r>
-              <a:rPr lang="en-US" sz="1400" dirty="0" smtClean="0"/>
-              <a:t>SIP contributions showed consistent growth. </a:t>
-            </a:r>
-            <a:endParaRPr lang="en-US" sz="1400" dirty="0" smtClean="0"/>
+              <a:t>Monthly SIP contributions showed consistent growth. </a:t>
+            </a:r>
           </a:p>
           <a:p>
             <a:pPr marL="457200" indent="-457200" algn="just">
@@ -6269,13 +6175,8 @@
             </a:pPr>
             <a:r>
               <a:rPr lang="en-US" sz="1400" dirty="0" smtClean="0"/>
-              <a:t>Investor </a:t>
-            </a:r>
-            <a:r>
-              <a:rPr lang="en-US" sz="1400" dirty="0" smtClean="0"/>
-              <a:t>participation expanded across multiple age groups. </a:t>
-            </a:r>
-            <a:endParaRPr lang="en-US" sz="1400" dirty="0" smtClean="0"/>
+              <a:t>Investor participation expanded across multiple age groups. </a:t>
+            </a:r>
           </a:p>
           <a:p>
             <a:pPr marL="457200" indent="-457200" algn="just">
@@ -6284,11 +6185,7 @@
             </a:pPr>
             <a:r>
               <a:rPr lang="en-US" sz="1400" dirty="0" smtClean="0"/>
-              <a:t>Category </a:t>
-            </a:r>
-            <a:r>
-              <a:rPr lang="en-US" sz="1400" dirty="0" smtClean="0"/>
-              <a:t>inflows varied significantly across market cycles</a:t>
+              <a:t>Category inflows varied significantly across market cycles</a:t>
             </a:r>
             <a:r>
               <a:rPr lang="en-US" sz="2000" dirty="0" smtClean="0"/>
@@ -6469,11 +6366,7 @@
           <a:p>
             <a:r>
               <a:rPr lang="en-US" sz="1400" dirty="0" smtClean="0"/>
-              <a:t>Fund </a:t>
-            </a:r>
-            <a:r>
-              <a:rPr lang="en-US" sz="1400" dirty="0" smtClean="0"/>
-              <a:t>Score</a:t>
+              <a:t>Fund Score</a:t>
             </a:r>
           </a:p>
           <a:p>
@@ -6490,7 +6383,6 @@
               <a:rPr lang="en-US" sz="1800" b="1" dirty="0" smtClean="0"/>
               <a:t>Outcome</a:t>
             </a:r>
-            <a:endParaRPr lang="en-US" sz="1800" b="1" dirty="0" smtClean="0"/>
           </a:p>
           <a:p>
             <a:r>
@@ -6520,11 +6412,7 @@
             </a:pPr>
             <a:r>
               <a:rPr lang="en-US" sz="1800" b="1" dirty="0" smtClean="0"/>
-              <a:t>Analysis </a:t>
-            </a:r>
-            <a:r>
-              <a:rPr lang="en-US" sz="1800" b="1" dirty="0" smtClean="0"/>
-              <a:t>Performed</a:t>
+              <a:t>Analysis Performed</a:t>
             </a:r>
           </a:p>
           <a:p>
@@ -6710,7 +6598,6 @@
               <a:rPr lang="en-US" sz="1400" dirty="0" smtClean="0"/>
               <a:t>Rolling 90-Day Sharpe Ratio </a:t>
             </a:r>
-            <a:endParaRPr lang="en-US" sz="1400" dirty="0" smtClean="0"/>
           </a:p>
           <a:p>
             <a:pPr lvl="1"/>
@@ -6745,7 +6632,6 @@
               <a:rPr lang="en-US" sz="1400" dirty="0" smtClean="0"/>
               <a:t>At-Risk Investor Detection </a:t>
             </a:r>
-            <a:endParaRPr lang="en-US" sz="1400" dirty="0" smtClean="0"/>
           </a:p>
           <a:p>
             <a:pPr lvl="1"/>
@@ -6771,11 +6657,7 @@
             <a:pPr lvl="1"/>
             <a:r>
               <a:rPr lang="en-US" sz="1400" dirty="0" smtClean="0"/>
-              <a:t>Fund Recommendation </a:t>
-            </a:r>
-            <a:r>
-              <a:rPr lang="en-US" sz="1400" dirty="0" smtClean="0"/>
-              <a:t>Engine</a:t>
+              <a:t>Fund Recommendation Engine</a:t>
             </a:r>
           </a:p>
           <a:p>
@@ -6788,27 +6670,14 @@
             </a:pPr>
             <a:r>
               <a:rPr lang="en-US" sz="1800" b="1" dirty="0" smtClean="0"/>
-              <a:t>Key </a:t>
-            </a:r>
-            <a:r>
-              <a:rPr lang="en-US" sz="1800" b="1" dirty="0" smtClean="0"/>
-              <a:t>Insight</a:t>
+              <a:t>Key Insight</a:t>
             </a:r>
           </a:p>
           <a:p>
             <a:r>
               <a:rPr lang="en-US" sz="1600" dirty="0" smtClean="0"/>
-              <a:t>Small </a:t>
-            </a:r>
-            <a:r>
-              <a:rPr lang="en-US" sz="1600" dirty="0" smtClean="0"/>
-              <a:t>Cap funds generated higher returns but carried significantly higher downside risk</a:t>
-            </a:r>
-            <a:r>
-              <a:rPr lang="en-US" sz="1600" dirty="0" smtClean="0"/>
-              <a:t>.</a:t>
-            </a:r>
-            <a:endParaRPr lang="en-US" sz="1600" dirty="0" smtClean="0"/>
+              <a:t>Small Cap funds generated higher returns but carried significantly higher downside risk.</a:t>
+            </a:r>
           </a:p>
           <a:p>
             <a:pPr>
@@ -6820,7 +6689,7 @@
       </p:sp>
       <p:pic>
         <p:nvPicPr>
-          <p:cNvPr id="5" name="Picture 4" descr="Screenshot 2026-06-10 233553.png"/>
+          <p:cNvPr id="6" name="Picture 5" descr="Screenshot 2026-06-12 143754.png"/>
           <p:cNvPicPr>
             <a:picLocks noChangeAspect="1"/>
           </p:cNvPicPr>
@@ -6834,8 +6703,8 @@
         </p:blipFill>
         <p:spPr>
           <a:xfrm>
-            <a:off x="3995936" y="2780928"/>
-            <a:ext cx="4426742" cy="2390486"/>
+            <a:off x="4067944" y="1988840"/>
+            <a:ext cx="4320480" cy="2956816"/>
           </a:xfrm>
           <a:prstGeom prst="rect">
             <a:avLst/>
@@ -7054,11 +6923,7 @@
             </a:pPr>
             <a:r>
               <a:rPr lang="en-US" sz="1100" b="1" dirty="0" smtClean="0"/>
-              <a:t>Page </a:t>
-            </a:r>
-            <a:r>
-              <a:rPr lang="en-US" sz="1100" b="1" dirty="0" smtClean="0"/>
-              <a:t>3 – Investor Analytics</a:t>
+              <a:t>Page 3 – Investor Analytics</a:t>
             </a:r>
           </a:p>
           <a:p>
@@ -7328,11 +7193,7 @@
             </a:pPr>
             <a:r>
               <a:rPr lang="en-US" sz="1600" dirty="0" smtClean="0"/>
-              <a:t>Generated actionable investment insights using advanced analytics</a:t>
-            </a:r>
-            <a:r>
-              <a:rPr lang="en-US" sz="1600" dirty="0" smtClean="0"/>
-              <a:t>.</a:t>
+              <a:t>Generated actionable investment insights using advanced analytics.</a:t>
             </a:r>
           </a:p>
           <a:p>

</xml_diff>